<commit_message>
Remove 무인체계 wording from README and PPTs
Co-Authored-By: Claude Opus 5.5 <noreply@anthropic.com>
</commit_message>
<xml_diff>
--- a/PPT/04_시리얼통신_GPS.pptx
+++ b/PPT/04_시리얼통신_GPS.pptx
@@ -4046,7 +4046,7 @@
                 <a:latin typeface="맑은 고딕"/>
                 <a:ea typeface="맑은 고딕"/>
               </a:rPr>
-              <a:t>무인체계 SW 개발 기초 세미나  ·  C# / WPF (.NET 8)</a:t>
+              <a:t>SW 개발 기초 세미나  ·  C# / WPF (.NET 8)</a:t>
             </a:r>
           </a:p>
         </p:txBody>
@@ -24780,7 +24780,7 @@
                 <a:latin typeface="맑은 고딕"/>
                 <a:ea typeface="맑은 고딕"/>
               </a:rPr>
-              <a:t>위경도는 각도라 거리 계산이 복잡. UTM은 m 단위 평면 좌표 → 거리 · 방향 계산이 쉬워 무인체계 경로 계획에 유리.</a:t>
+              <a:t>위경도는 각도라 거리 계산이 복잡. UTM은 m 단위 평면 좌표 → 거리 · 방향 계산이 쉬워 경로 계획 · 지도 표시에 유리.</a:t>
             </a:r>
           </a:p>
         </p:txBody>

</xml_diff>